<commit_message>
Update final deliverables (docx, pdf, pptx)
</commit_message>
<xml_diff>
--- a/deliverables/SRAM_AI_Adoption_Playbook_Final.pptx
+++ b/deliverables/SRAM_AI_Adoption_Playbook_Final.pptx
@@ -25,6 +25,7 @@
     <p:sldId id="273" r:id="rId19"/>
     <p:sldId id="274" r:id="rId20"/>
     <p:sldId id="276" r:id="rId21"/>
+    <p:sldId id="278" r:id="rId22"/>
   </p:sldIdLst>
   <p:sldSz cx="12192000" cy="6858000"/>
   <p:notesSz cx="6858000" cy="9144000"/>
@@ -5699,6 +5700,47 @@
           </a:p>
         </p:txBody>
       </p:sp>
+      <p:sp>
+        <p:nvSpPr>
+          <p:cNvPr id="62" name="TextBox 61">
+            <a:extLst>
+              <a:ext uri="{FF2B5EF4-FFF2-40B4-BE49-F238E27FC236}">
+                <a16:creationId xmlns:a16="http://schemas.microsoft.com/office/drawing/2014/main" id="{8A825D22-DCF8-21D8-17EB-B2F1FA446F2C}"/>
+              </a:ext>
+            </a:extLst>
+          </p:cNvPr>
+          <p:cNvSpPr txBox="1"/>
+          <p:nvPr/>
+        </p:nvSpPr>
+        <p:spPr>
+          <a:xfrm>
+            <a:off x="0" y="0"/>
+            <a:ext cx="274625" cy="261610"/>
+          </a:xfrm>
+          <a:prstGeom prst="rect">
+            <a:avLst/>
+          </a:prstGeom>
+          <a:noFill/>
+        </p:spPr>
+        <p:txBody>
+          <a:bodyPr wrap="square" rtlCol="0">
+            <a:spAutoFit/>
+          </a:bodyPr>
+          <a:lstStyle/>
+          <a:p>
+            <a:r>
+              <a:rPr lang="en-US" sz="1100" i="1" dirty="0">
+                <a:solidFill>
+                  <a:schemeClr val="bg1">
+                    <a:lumMod val="50000"/>
+                  </a:schemeClr>
+                </a:solidFill>
+              </a:rPr>
+              <a:t>D</a:t>
+            </a:r>
+          </a:p>
+        </p:txBody>
+      </p:sp>
     </p:spTree>
   </p:cSld>
   <p:clrMapOvr>
@@ -7549,6 +7591,47 @@
           </a:p>
         </p:txBody>
       </p:sp>
+      <p:sp>
+        <p:nvSpPr>
+          <p:cNvPr id="48" name="TextBox 47">
+            <a:extLst>
+              <a:ext uri="{FF2B5EF4-FFF2-40B4-BE49-F238E27FC236}">
+                <a16:creationId xmlns:a16="http://schemas.microsoft.com/office/drawing/2014/main" id="{4F83F1DB-1161-577A-E4F8-65D81B476CF4}"/>
+              </a:ext>
+            </a:extLst>
+          </p:cNvPr>
+          <p:cNvSpPr txBox="1"/>
+          <p:nvPr/>
+        </p:nvSpPr>
+        <p:spPr>
+          <a:xfrm>
+            <a:off x="0" y="0"/>
+            <a:ext cx="274625" cy="261610"/>
+          </a:xfrm>
+          <a:prstGeom prst="rect">
+            <a:avLst/>
+          </a:prstGeom>
+          <a:noFill/>
+        </p:spPr>
+        <p:txBody>
+          <a:bodyPr wrap="square" rtlCol="0">
+            <a:spAutoFit/>
+          </a:bodyPr>
+          <a:lstStyle/>
+          <a:p>
+            <a:r>
+              <a:rPr lang="en-US" sz="1100" i="1" dirty="0">
+                <a:solidFill>
+                  <a:schemeClr val="bg1">
+                    <a:lumMod val="50000"/>
+                  </a:schemeClr>
+                </a:solidFill>
+              </a:rPr>
+              <a:t>D</a:t>
+            </a:r>
+          </a:p>
+        </p:txBody>
+      </p:sp>
     </p:spTree>
   </p:cSld>
   <p:clrMapOvr>
@@ -9746,6 +9829,47 @@
           </a:p>
         </p:txBody>
       </p:sp>
+      <p:sp>
+        <p:nvSpPr>
+          <p:cNvPr id="55" name="TextBox 54">
+            <a:extLst>
+              <a:ext uri="{FF2B5EF4-FFF2-40B4-BE49-F238E27FC236}">
+                <a16:creationId xmlns:a16="http://schemas.microsoft.com/office/drawing/2014/main" id="{31868227-5045-7A71-C8F4-1C525AC63225}"/>
+              </a:ext>
+            </a:extLst>
+          </p:cNvPr>
+          <p:cNvSpPr txBox="1"/>
+          <p:nvPr/>
+        </p:nvSpPr>
+        <p:spPr>
+          <a:xfrm>
+            <a:off x="0" y="0"/>
+            <a:ext cx="274625" cy="261610"/>
+          </a:xfrm>
+          <a:prstGeom prst="rect">
+            <a:avLst/>
+          </a:prstGeom>
+          <a:noFill/>
+        </p:spPr>
+        <p:txBody>
+          <a:bodyPr wrap="square" rtlCol="0">
+            <a:spAutoFit/>
+          </a:bodyPr>
+          <a:lstStyle/>
+          <a:p>
+            <a:r>
+              <a:rPr lang="en-US" sz="1100" i="1" dirty="0">
+                <a:solidFill>
+                  <a:schemeClr val="bg1">
+                    <a:lumMod val="50000"/>
+                  </a:schemeClr>
+                </a:solidFill>
+              </a:rPr>
+              <a:t>D</a:t>
+            </a:r>
+          </a:p>
+        </p:txBody>
+      </p:sp>
     </p:spTree>
   </p:cSld>
   <p:clrMapOvr>
@@ -11760,6 +11884,47 @@
           </a:p>
         </p:txBody>
       </p:sp>
+      <p:sp>
+        <p:nvSpPr>
+          <p:cNvPr id="52" name="TextBox 51">
+            <a:extLst>
+              <a:ext uri="{FF2B5EF4-FFF2-40B4-BE49-F238E27FC236}">
+                <a16:creationId xmlns:a16="http://schemas.microsoft.com/office/drawing/2014/main" id="{205C7781-870A-D4EC-4107-16C67C036090}"/>
+              </a:ext>
+            </a:extLst>
+          </p:cNvPr>
+          <p:cNvSpPr txBox="1"/>
+          <p:nvPr/>
+        </p:nvSpPr>
+        <p:spPr>
+          <a:xfrm>
+            <a:off x="0" y="0"/>
+            <a:ext cx="274625" cy="261610"/>
+          </a:xfrm>
+          <a:prstGeom prst="rect">
+            <a:avLst/>
+          </a:prstGeom>
+          <a:noFill/>
+        </p:spPr>
+        <p:txBody>
+          <a:bodyPr wrap="square" rtlCol="0">
+            <a:spAutoFit/>
+          </a:bodyPr>
+          <a:lstStyle/>
+          <a:p>
+            <a:r>
+              <a:rPr lang="en-US" sz="1100" i="1" dirty="0">
+                <a:solidFill>
+                  <a:schemeClr val="bg1">
+                    <a:lumMod val="50000"/>
+                  </a:schemeClr>
+                </a:solidFill>
+              </a:rPr>
+              <a:t>D</a:t>
+            </a:r>
+          </a:p>
+        </p:txBody>
+      </p:sp>
     </p:spTree>
   </p:cSld>
   <p:clrMapOvr>
@@ -14519,6 +14684,7 @@
               </a:defRPr>
             </a:pPr>
             <a:r>
+              <a:rPr dirty="0"/>
               <a:t>CSAT Monitoring</a:t>
             </a:r>
           </a:p>
@@ -15283,6 +15449,47 @@
               <a:t>12</a:t>
             </a:r>
             <a:endParaRPr dirty="0"/>
+          </a:p>
+        </p:txBody>
+      </p:sp>
+      <p:sp>
+        <p:nvSpPr>
+          <p:cNvPr id="31" name="TextBox 30">
+            <a:extLst>
+              <a:ext uri="{FF2B5EF4-FFF2-40B4-BE49-F238E27FC236}">
+                <a16:creationId xmlns:a16="http://schemas.microsoft.com/office/drawing/2014/main" id="{7DDDC3C3-0E42-D4B9-93DB-1072C533B8BE}"/>
+              </a:ext>
+            </a:extLst>
+          </p:cNvPr>
+          <p:cNvSpPr txBox="1"/>
+          <p:nvPr/>
+        </p:nvSpPr>
+        <p:spPr>
+          <a:xfrm>
+            <a:off x="0" y="0"/>
+            <a:ext cx="274625" cy="261610"/>
+          </a:xfrm>
+          <a:prstGeom prst="rect">
+            <a:avLst/>
+          </a:prstGeom>
+          <a:noFill/>
+        </p:spPr>
+        <p:txBody>
+          <a:bodyPr wrap="square" rtlCol="0">
+            <a:spAutoFit/>
+          </a:bodyPr>
+          <a:lstStyle/>
+          <a:p>
+            <a:r>
+              <a:rPr lang="en-US" sz="1100" i="1" dirty="0">
+                <a:solidFill>
+                  <a:schemeClr val="bg1">
+                    <a:lumMod val="50000"/>
+                  </a:schemeClr>
+                </a:solidFill>
+              </a:rPr>
+              <a:t>D</a:t>
+            </a:r>
           </a:p>
         </p:txBody>
       </p:sp>
@@ -16445,6 +16652,47 @@
           </a:p>
         </p:txBody>
       </p:sp>
+      <p:sp>
+        <p:nvSpPr>
+          <p:cNvPr id="30" name="TextBox 29">
+            <a:extLst>
+              <a:ext uri="{FF2B5EF4-FFF2-40B4-BE49-F238E27FC236}">
+                <a16:creationId xmlns:a16="http://schemas.microsoft.com/office/drawing/2014/main" id="{85BBA263-9099-05D0-F200-5B37376BD926}"/>
+              </a:ext>
+            </a:extLst>
+          </p:cNvPr>
+          <p:cNvSpPr txBox="1"/>
+          <p:nvPr/>
+        </p:nvSpPr>
+        <p:spPr>
+          <a:xfrm>
+            <a:off x="0" y="0"/>
+            <a:ext cx="274625" cy="261610"/>
+          </a:xfrm>
+          <a:prstGeom prst="rect">
+            <a:avLst/>
+          </a:prstGeom>
+          <a:noFill/>
+        </p:spPr>
+        <p:txBody>
+          <a:bodyPr wrap="square" rtlCol="0">
+            <a:spAutoFit/>
+          </a:bodyPr>
+          <a:lstStyle/>
+          <a:p>
+            <a:r>
+              <a:rPr lang="en-US" sz="1100" i="1" dirty="0">
+                <a:solidFill>
+                  <a:schemeClr val="bg1">
+                    <a:lumMod val="50000"/>
+                  </a:schemeClr>
+                </a:solidFill>
+              </a:rPr>
+              <a:t>E</a:t>
+            </a:r>
+          </a:p>
+        </p:txBody>
+      </p:sp>
     </p:spTree>
   </p:cSld>
   <p:clrMapOvr>
@@ -18808,6 +19056,47 @@
           </a:p>
         </p:txBody>
       </p:sp>
+      <p:sp>
+        <p:nvSpPr>
+          <p:cNvPr id="22" name="TextBox 21">
+            <a:extLst>
+              <a:ext uri="{FF2B5EF4-FFF2-40B4-BE49-F238E27FC236}">
+                <a16:creationId xmlns:a16="http://schemas.microsoft.com/office/drawing/2014/main" id="{0B00E3F4-83D0-4C71-6450-0166FA591563}"/>
+              </a:ext>
+            </a:extLst>
+          </p:cNvPr>
+          <p:cNvSpPr txBox="1"/>
+          <p:nvPr/>
+        </p:nvSpPr>
+        <p:spPr>
+          <a:xfrm>
+            <a:off x="0" y="0"/>
+            <a:ext cx="274625" cy="261610"/>
+          </a:xfrm>
+          <a:prstGeom prst="rect">
+            <a:avLst/>
+          </a:prstGeom>
+          <a:noFill/>
+        </p:spPr>
+        <p:txBody>
+          <a:bodyPr wrap="square" rtlCol="0">
+            <a:spAutoFit/>
+          </a:bodyPr>
+          <a:lstStyle/>
+          <a:p>
+            <a:r>
+              <a:rPr lang="en-US" sz="1100" i="1" dirty="0">
+                <a:solidFill>
+                  <a:schemeClr val="bg1">
+                    <a:lumMod val="50000"/>
+                  </a:schemeClr>
+                </a:solidFill>
+              </a:rPr>
+              <a:t>E</a:t>
+            </a:r>
+          </a:p>
+        </p:txBody>
+      </p:sp>
     </p:spTree>
   </p:cSld>
   <p:clrMapOvr>
@@ -19325,6 +19614,47 @@
           </a:p>
         </p:txBody>
       </p:sp>
+      <p:sp>
+        <p:nvSpPr>
+          <p:cNvPr id="15" name="TextBox 14">
+            <a:extLst>
+              <a:ext uri="{FF2B5EF4-FFF2-40B4-BE49-F238E27FC236}">
+                <a16:creationId xmlns:a16="http://schemas.microsoft.com/office/drawing/2014/main" id="{B535E637-ADC9-420A-7435-7689E95418D8}"/>
+              </a:ext>
+            </a:extLst>
+          </p:cNvPr>
+          <p:cNvSpPr txBox="1"/>
+          <p:nvPr/>
+        </p:nvSpPr>
+        <p:spPr>
+          <a:xfrm>
+            <a:off x="0" y="0"/>
+            <a:ext cx="274625" cy="261610"/>
+          </a:xfrm>
+          <a:prstGeom prst="rect">
+            <a:avLst/>
+          </a:prstGeom>
+          <a:noFill/>
+        </p:spPr>
+        <p:txBody>
+          <a:bodyPr wrap="square" rtlCol="0">
+            <a:spAutoFit/>
+          </a:bodyPr>
+          <a:lstStyle/>
+          <a:p>
+            <a:r>
+              <a:rPr lang="en-US" sz="1100" i="1" dirty="0">
+                <a:solidFill>
+                  <a:schemeClr val="bg1">
+                    <a:lumMod val="50000"/>
+                  </a:schemeClr>
+                </a:solidFill>
+              </a:rPr>
+              <a:t>E</a:t>
+            </a:r>
+          </a:p>
+        </p:txBody>
+      </p:sp>
     </p:spTree>
   </p:cSld>
   <p:clrMapOvr>
@@ -20246,8 +20576,8 @@
         </p:nvSpPr>
         <p:spPr>
           <a:xfrm>
-            <a:off x="731520" y="5486400"/>
-            <a:ext cx="10698480" cy="411480"/>
+            <a:off x="731520" y="5486399"/>
+            <a:ext cx="10698480" cy="436687"/>
           </a:xfrm>
           <a:prstGeom prst="roundRect">
             <a:avLst>
@@ -20339,7 +20669,7 @@
         <p:spPr>
           <a:xfrm>
             <a:off x="1097280" y="5522976"/>
-            <a:ext cx="10058400" cy="320040"/>
+            <a:ext cx="10058400" cy="400110"/>
           </a:xfrm>
           <a:prstGeom prst="rect">
             <a:avLst/>
@@ -20361,6 +20691,7 @@
               </a:defRPr>
             </a:pPr>
             <a:r>
+              <a:rPr sz="2000" dirty="0"/>
               <a:t>Hardware sells data access  →  Data improves performance  →  Performance sells hardware</a:t>
             </a:r>
           </a:p>
@@ -20434,6 +20765,47 @@
             </a:pPr>
             <a:r>
               <a:t>13</a:t>
+            </a:r>
+          </a:p>
+        </p:txBody>
+      </p:sp>
+      <p:sp>
+        <p:nvSpPr>
+          <p:cNvPr id="30" name="TextBox 29">
+            <a:extLst>
+              <a:ext uri="{FF2B5EF4-FFF2-40B4-BE49-F238E27FC236}">
+                <a16:creationId xmlns:a16="http://schemas.microsoft.com/office/drawing/2014/main" id="{4535F142-646D-6566-1F2E-7A8642B71C84}"/>
+              </a:ext>
+            </a:extLst>
+          </p:cNvPr>
+          <p:cNvSpPr txBox="1"/>
+          <p:nvPr/>
+        </p:nvSpPr>
+        <p:spPr>
+          <a:xfrm>
+            <a:off x="0" y="0"/>
+            <a:ext cx="274625" cy="261610"/>
+          </a:xfrm>
+          <a:prstGeom prst="rect">
+            <a:avLst/>
+          </a:prstGeom>
+          <a:noFill/>
+        </p:spPr>
+        <p:txBody>
+          <a:bodyPr wrap="square" rtlCol="0">
+            <a:spAutoFit/>
+          </a:bodyPr>
+          <a:lstStyle/>
+          <a:p>
+            <a:r>
+              <a:rPr lang="en-US" sz="1100" i="1" dirty="0">
+                <a:solidFill>
+                  <a:schemeClr val="bg1">
+                    <a:lumMod val="50000"/>
+                  </a:schemeClr>
+                </a:solidFill>
+              </a:rPr>
+              <a:t>E</a:t>
             </a:r>
           </a:p>
         </p:txBody>
@@ -21962,6 +22334,47 @@
           </a:p>
         </p:txBody>
       </p:sp>
+      <p:sp>
+        <p:nvSpPr>
+          <p:cNvPr id="13" name="TextBox 12">
+            <a:extLst>
+              <a:ext uri="{FF2B5EF4-FFF2-40B4-BE49-F238E27FC236}">
+                <a16:creationId xmlns:a16="http://schemas.microsoft.com/office/drawing/2014/main" id="{525C5270-3022-B6B6-CEC5-D4D9338BC5D1}"/>
+              </a:ext>
+            </a:extLst>
+          </p:cNvPr>
+          <p:cNvSpPr txBox="1"/>
+          <p:nvPr/>
+        </p:nvSpPr>
+        <p:spPr>
+          <a:xfrm>
+            <a:off x="0" y="0"/>
+            <a:ext cx="274625" cy="261610"/>
+          </a:xfrm>
+          <a:prstGeom prst="rect">
+            <a:avLst/>
+          </a:prstGeom>
+          <a:noFill/>
+        </p:spPr>
+        <p:txBody>
+          <a:bodyPr wrap="square" rtlCol="0">
+            <a:spAutoFit/>
+          </a:bodyPr>
+          <a:lstStyle/>
+          <a:p>
+            <a:r>
+              <a:rPr lang="en-US" sz="1100" i="1" dirty="0">
+                <a:solidFill>
+                  <a:schemeClr val="bg1">
+                    <a:lumMod val="50000"/>
+                  </a:schemeClr>
+                </a:solidFill>
+              </a:rPr>
+              <a:t>E</a:t>
+            </a:r>
+          </a:p>
+        </p:txBody>
+      </p:sp>
     </p:spTree>
   </p:cSld>
   <p:clrMapOvr>
@@ -22842,6 +23255,47 @@
           </a:extLst>
         </p:spPr>
       </p:pic>
+      <p:sp>
+        <p:nvSpPr>
+          <p:cNvPr id="9" name="TextBox 8">
+            <a:extLst>
+              <a:ext uri="{FF2B5EF4-FFF2-40B4-BE49-F238E27FC236}">
+                <a16:creationId xmlns:a16="http://schemas.microsoft.com/office/drawing/2014/main" id="{4DDF1FEE-3B21-91DF-901B-5F6CBA12B47A}"/>
+              </a:ext>
+            </a:extLst>
+          </p:cNvPr>
+          <p:cNvSpPr txBox="1"/>
+          <p:nvPr/>
+        </p:nvSpPr>
+        <p:spPr>
+          <a:xfrm>
+            <a:off x="0" y="0"/>
+            <a:ext cx="274625" cy="261610"/>
+          </a:xfrm>
+          <a:prstGeom prst="rect">
+            <a:avLst/>
+          </a:prstGeom>
+          <a:noFill/>
+        </p:spPr>
+        <p:txBody>
+          <a:bodyPr wrap="square" rtlCol="0">
+            <a:spAutoFit/>
+          </a:bodyPr>
+          <a:lstStyle/>
+          <a:p>
+            <a:r>
+              <a:rPr lang="en-US" sz="1100" i="1" dirty="0">
+                <a:solidFill>
+                  <a:schemeClr val="bg1">
+                    <a:lumMod val="50000"/>
+                  </a:schemeClr>
+                </a:solidFill>
+              </a:rPr>
+              <a:t>D</a:t>
+            </a:r>
+          </a:p>
+        </p:txBody>
+      </p:sp>
     </p:spTree>
   </p:cSld>
   <p:clrMapOvr>
@@ -22966,6 +23420,7 @@
               </a:defRPr>
             </a:pPr>
             <a:r>
+              <a:rPr dirty="0"/>
               <a:t>Three risks worth naming before the decision</a:t>
             </a:r>
           </a:p>
@@ -23687,7 +24142,316 @@
           </a:p>
         </p:txBody>
       </p:sp>
+      <p:sp>
+        <p:nvSpPr>
+          <p:cNvPr id="23" name="TextBox 22">
+            <a:extLst>
+              <a:ext uri="{FF2B5EF4-FFF2-40B4-BE49-F238E27FC236}">
+                <a16:creationId xmlns:a16="http://schemas.microsoft.com/office/drawing/2014/main" id="{AE87AA26-E63A-A6B2-809B-DED0D8E0CE75}"/>
+              </a:ext>
+            </a:extLst>
+          </p:cNvPr>
+          <p:cNvSpPr txBox="1"/>
+          <p:nvPr/>
+        </p:nvSpPr>
+        <p:spPr>
+          <a:xfrm>
+            <a:off x="0" y="0"/>
+            <a:ext cx="274625" cy="261610"/>
+          </a:xfrm>
+          <a:prstGeom prst="rect">
+            <a:avLst/>
+          </a:prstGeom>
+          <a:noFill/>
+        </p:spPr>
+        <p:txBody>
+          <a:bodyPr wrap="square" rtlCol="0">
+            <a:spAutoFit/>
+          </a:bodyPr>
+          <a:lstStyle/>
+          <a:p>
+            <a:r>
+              <a:rPr lang="en-US" sz="1100" i="1" dirty="0">
+                <a:solidFill>
+                  <a:schemeClr val="bg1">
+                    <a:lumMod val="50000"/>
+                  </a:schemeClr>
+                </a:solidFill>
+              </a:rPr>
+              <a:t>W</a:t>
+            </a:r>
+          </a:p>
+        </p:txBody>
+      </p:sp>
     </p:spTree>
+  </p:cSld>
+  <p:clrMapOvr>
+    <a:masterClrMapping/>
+  </p:clrMapOvr>
+</p:sld>
+</file>
+
+<file path=ppt/slides/slide21.xml><?xml version="1.0" encoding="utf-8"?>
+<p:sld xmlns:a="http://schemas.openxmlformats.org/drawingml/2006/main" xmlns:r="http://schemas.openxmlformats.org/officeDocument/2006/relationships" xmlns:p="http://schemas.openxmlformats.org/presentationml/2006/main">
+  <p:cSld>
+    <p:bg>
+      <p:bgPr>
+        <a:solidFill>
+          <a:srgbClr val="F5F5F3"/>
+        </a:solidFill>
+        <a:effectLst/>
+      </p:bgPr>
+    </p:bg>
+    <p:spTree>
+      <p:nvGrpSpPr>
+        <p:cNvPr id="1" name="">
+          <a:extLst>
+            <a:ext uri="{FF2B5EF4-FFF2-40B4-BE49-F238E27FC236}">
+              <a16:creationId xmlns:a16="http://schemas.microsoft.com/office/drawing/2014/main" id="{9B575A76-1521-DD41-AE4C-75A2D4251E5C}"/>
+            </a:ext>
+          </a:extLst>
+        </p:cNvPr>
+        <p:cNvGrpSpPr/>
+        <p:nvPr/>
+      </p:nvGrpSpPr>
+      <p:grpSpPr>
+        <a:xfrm>
+          <a:off x="0" y="0"/>
+          <a:ext cx="0" cy="0"/>
+          <a:chOff x="0" y="0"/>
+          <a:chExt cx="0" cy="0"/>
+        </a:xfrm>
+      </p:grpSpPr>
+      <p:pic>
+        <p:nvPicPr>
+          <p:cNvPr id="2" name="Picture 1" descr="sram_logo.png">
+            <a:extLst>
+              <a:ext uri="{FF2B5EF4-FFF2-40B4-BE49-F238E27FC236}">
+                <a16:creationId xmlns:a16="http://schemas.microsoft.com/office/drawing/2014/main" id="{CF24803A-1CF0-3010-9448-3F263666F26C}"/>
+              </a:ext>
+            </a:extLst>
+          </p:cNvPr>
+          <p:cNvPicPr>
+            <a:picLocks noChangeAspect="1"/>
+          </p:cNvPicPr>
+          <p:nvPr/>
+        </p:nvPicPr>
+        <p:blipFill>
+          <a:blip r:embed="rId2"/>
+          <a:stretch>
+            <a:fillRect/>
+          </a:stretch>
+        </p:blipFill>
+        <p:spPr>
+          <a:xfrm>
+            <a:off x="10820095" y="228600"/>
+            <a:ext cx="1097280" cy="141353"/>
+          </a:xfrm>
+          <a:prstGeom prst="rect">
+            <a:avLst/>
+          </a:prstGeom>
+        </p:spPr>
+      </p:pic>
+      <p:sp>
+        <p:nvSpPr>
+          <p:cNvPr id="4" name="TextBox 3">
+            <a:extLst>
+              <a:ext uri="{FF2B5EF4-FFF2-40B4-BE49-F238E27FC236}">
+                <a16:creationId xmlns:a16="http://schemas.microsoft.com/office/drawing/2014/main" id="{B9A2744D-4CD9-2181-32A5-7572D48D26F0}"/>
+              </a:ext>
+            </a:extLst>
+          </p:cNvPr>
+          <p:cNvSpPr txBox="1"/>
+          <p:nvPr/>
+        </p:nvSpPr>
+        <p:spPr>
+          <a:xfrm>
+            <a:off x="731520" y="548640"/>
+            <a:ext cx="9601200" cy="502920"/>
+          </a:xfrm>
+          <a:prstGeom prst="rect">
+            <a:avLst/>
+          </a:prstGeom>
+          <a:noFill/>
+        </p:spPr>
+        <p:txBody>
+          <a:bodyPr wrap="square">
+            <a:spAutoFit/>
+          </a:bodyPr>
+          <a:lstStyle/>
+          <a:p>
+            <a:pPr algn="l">
+              <a:defRPr sz="2600" b="1" i="0">
+                <a:solidFill>
+                  <a:srgbClr val="1C1C1E"/>
+                </a:solidFill>
+                <a:latin typeface="Calibri"/>
+              </a:defRPr>
+            </a:pPr>
+            <a:r>
+              <a:rPr lang="en-US" dirty="0"/>
+              <a:t>Questions</a:t>
+            </a:r>
+            <a:endParaRPr dirty="0"/>
+          </a:p>
+        </p:txBody>
+      </p:sp>
+      <p:sp>
+        <p:nvSpPr>
+          <p:cNvPr id="21" name="TextBox 20">
+            <a:extLst>
+              <a:ext uri="{FF2B5EF4-FFF2-40B4-BE49-F238E27FC236}">
+                <a16:creationId xmlns:a16="http://schemas.microsoft.com/office/drawing/2014/main" id="{B17723D4-B50E-C892-0560-8509AD6E2878}"/>
+              </a:ext>
+            </a:extLst>
+          </p:cNvPr>
+          <p:cNvSpPr txBox="1"/>
+          <p:nvPr/>
+        </p:nvSpPr>
+        <p:spPr>
+          <a:xfrm>
+            <a:off x="731520" y="6446520"/>
+            <a:ext cx="4572000" cy="274320"/>
+          </a:xfrm>
+          <a:prstGeom prst="rect">
+            <a:avLst/>
+          </a:prstGeom>
+          <a:noFill/>
+        </p:spPr>
+        <p:txBody>
+          <a:bodyPr wrap="square">
+            <a:spAutoFit/>
+          </a:bodyPr>
+          <a:lstStyle/>
+          <a:p>
+            <a:pPr algn="l">
+              <a:defRPr sz="800" b="0" i="0">
+                <a:solidFill>
+                  <a:srgbClr val="767676"/>
+                </a:solidFill>
+                <a:latin typeface="Calibri"/>
+              </a:defRPr>
+            </a:pPr>
+            <a:r>
+              <a:t>SRAM AI Adoption Playbook</a:t>
+            </a:r>
+          </a:p>
+        </p:txBody>
+      </p:sp>
+      <p:sp>
+        <p:nvSpPr>
+          <p:cNvPr id="22" name="TextBox 21">
+            <a:extLst>
+              <a:ext uri="{FF2B5EF4-FFF2-40B4-BE49-F238E27FC236}">
+                <a16:creationId xmlns:a16="http://schemas.microsoft.com/office/drawing/2014/main" id="{BB9F0245-9E4B-86F7-5CF1-430CD8A457A8}"/>
+              </a:ext>
+            </a:extLst>
+          </p:cNvPr>
+          <p:cNvSpPr txBox="1"/>
+          <p:nvPr/>
+        </p:nvSpPr>
+        <p:spPr>
+          <a:xfrm>
+            <a:off x="10515600" y="6446520"/>
+            <a:ext cx="1371600" cy="215444"/>
+          </a:xfrm>
+          <a:prstGeom prst="rect">
+            <a:avLst/>
+          </a:prstGeom>
+          <a:noFill/>
+        </p:spPr>
+        <p:txBody>
+          <a:bodyPr wrap="square">
+            <a:spAutoFit/>
+          </a:bodyPr>
+          <a:lstStyle/>
+          <a:p>
+            <a:pPr algn="r">
+              <a:defRPr sz="800" b="0" i="0">
+                <a:solidFill>
+                  <a:srgbClr val="767676"/>
+                </a:solidFill>
+                <a:latin typeface="Calibri"/>
+              </a:defRPr>
+            </a:pPr>
+            <a:r>
+              <a:rPr dirty="0"/>
+              <a:t>1</a:t>
+            </a:r>
+            <a:r>
+              <a:rPr lang="en-US" dirty="0"/>
+              <a:t>7</a:t>
+            </a:r>
+            <a:endParaRPr dirty="0"/>
+          </a:p>
+        </p:txBody>
+      </p:sp>
+      <p:pic>
+        <p:nvPicPr>
+          <p:cNvPr id="29" name="Picture 28">
+            <a:extLst>
+              <a:ext uri="{FF2B5EF4-FFF2-40B4-BE49-F238E27FC236}">
+                <a16:creationId xmlns:a16="http://schemas.microsoft.com/office/drawing/2014/main" id="{08BD80EF-7163-341D-992E-9C3503E60ECF}"/>
+              </a:ext>
+            </a:extLst>
+          </p:cNvPr>
+          <p:cNvPicPr>
+            <a:picLocks noChangeAspect="1"/>
+          </p:cNvPicPr>
+          <p:nvPr/>
+        </p:nvPicPr>
+        <p:blipFill>
+          <a:blip r:embed="rId3"/>
+          <a:stretch>
+            <a:fillRect/>
+          </a:stretch>
+        </p:blipFill>
+        <p:spPr>
+          <a:xfrm>
+            <a:off x="6518030" y="1852402"/>
+            <a:ext cx="4909151" cy="3422983"/>
+          </a:xfrm>
+          <a:prstGeom prst="rect">
+            <a:avLst/>
+          </a:prstGeom>
+        </p:spPr>
+      </p:pic>
+      <p:pic>
+        <p:nvPicPr>
+          <p:cNvPr id="34" name="Picture 33">
+            <a:extLst>
+              <a:ext uri="{FF2B5EF4-FFF2-40B4-BE49-F238E27FC236}">
+                <a16:creationId xmlns:a16="http://schemas.microsoft.com/office/drawing/2014/main" id="{89FDBF84-F797-C937-CE5F-3D0AC0B9EA90}"/>
+              </a:ext>
+            </a:extLst>
+          </p:cNvPr>
+          <p:cNvPicPr>
+            <a:picLocks noChangeAspect="1"/>
+          </p:cNvPicPr>
+          <p:nvPr/>
+        </p:nvPicPr>
+        <p:blipFill>
+          <a:blip r:embed="rId4"/>
+          <a:stretch>
+            <a:fillRect/>
+          </a:stretch>
+        </p:blipFill>
+        <p:spPr>
+          <a:xfrm>
+            <a:off x="731520" y="1852401"/>
+            <a:ext cx="6284122" cy="3424355"/>
+          </a:xfrm>
+          <a:prstGeom prst="rect">
+            <a:avLst/>
+          </a:prstGeom>
+        </p:spPr>
+      </p:pic>
+    </p:spTree>
+    <p:extLst>
+      <p:ext uri="{BB962C8B-B14F-4D97-AF65-F5344CB8AC3E}">
+        <p14:creationId xmlns:p14="http://schemas.microsoft.com/office/powerpoint/2010/main" val="391770112"/>
+      </p:ext>
+    </p:extLst>
   </p:cSld>
   <p:clrMapOvr>
     <a:masterClrMapping/>
@@ -26049,6 +26813,47 @@
           </a:fontRef>
         </p:style>
       </p:cxnSp>
+      <p:sp>
+        <p:nvSpPr>
+          <p:cNvPr id="31" name="TextBox 30">
+            <a:extLst>
+              <a:ext uri="{FF2B5EF4-FFF2-40B4-BE49-F238E27FC236}">
+                <a16:creationId xmlns:a16="http://schemas.microsoft.com/office/drawing/2014/main" id="{75A4A990-DB43-C0F2-7D15-E0E8BB156E39}"/>
+              </a:ext>
+            </a:extLst>
+          </p:cNvPr>
+          <p:cNvSpPr txBox="1"/>
+          <p:nvPr/>
+        </p:nvSpPr>
+        <p:spPr>
+          <a:xfrm>
+            <a:off x="0" y="0"/>
+            <a:ext cx="274625" cy="261610"/>
+          </a:xfrm>
+          <a:prstGeom prst="rect">
+            <a:avLst/>
+          </a:prstGeom>
+          <a:noFill/>
+        </p:spPr>
+        <p:txBody>
+          <a:bodyPr wrap="square" rtlCol="0">
+            <a:spAutoFit/>
+          </a:bodyPr>
+          <a:lstStyle/>
+          <a:p>
+            <a:r>
+              <a:rPr lang="en-US" sz="1100" i="1" dirty="0">
+                <a:solidFill>
+                  <a:schemeClr val="bg1">
+                    <a:lumMod val="50000"/>
+                  </a:schemeClr>
+                </a:solidFill>
+              </a:rPr>
+              <a:t>D</a:t>
+            </a:r>
+          </a:p>
+        </p:txBody>
+      </p:sp>
     </p:spTree>
     <p:extLst>
       <p:ext uri="{BB962C8B-B14F-4D97-AF65-F5344CB8AC3E}">
@@ -26142,6 +26947,7 @@
               </a:defRPr>
             </a:pPr>
             <a:r>
+              <a:rPr dirty="0"/>
               <a:t>THE STRATEGY</a:t>
             </a:r>
           </a:p>
@@ -27895,6 +28701,47 @@
             </a:pPr>
             <a:r>
               <a:t>3</a:t>
+            </a:r>
+          </a:p>
+        </p:txBody>
+      </p:sp>
+      <p:sp>
+        <p:nvSpPr>
+          <p:cNvPr id="42" name="TextBox 41">
+            <a:extLst>
+              <a:ext uri="{FF2B5EF4-FFF2-40B4-BE49-F238E27FC236}">
+                <a16:creationId xmlns:a16="http://schemas.microsoft.com/office/drawing/2014/main" id="{4DF2C1EC-4D9D-AFA8-72B9-9A54A839186D}"/>
+              </a:ext>
+            </a:extLst>
+          </p:cNvPr>
+          <p:cNvSpPr txBox="1"/>
+          <p:nvPr/>
+        </p:nvSpPr>
+        <p:spPr>
+          <a:xfrm>
+            <a:off x="0" y="0"/>
+            <a:ext cx="274625" cy="261610"/>
+          </a:xfrm>
+          <a:prstGeom prst="rect">
+            <a:avLst/>
+          </a:prstGeom>
+          <a:noFill/>
+        </p:spPr>
+        <p:txBody>
+          <a:bodyPr wrap="square" rtlCol="0">
+            <a:spAutoFit/>
+          </a:bodyPr>
+          <a:lstStyle/>
+          <a:p>
+            <a:r>
+              <a:rPr lang="en-US" sz="1100" i="1" dirty="0">
+                <a:solidFill>
+                  <a:schemeClr val="bg1">
+                    <a:lumMod val="50000"/>
+                  </a:schemeClr>
+                </a:solidFill>
+              </a:rPr>
+              <a:t>W</a:t>
             </a:r>
           </a:p>
         </p:txBody>
@@ -28956,6 +29803,47 @@
           </a:p>
         </p:txBody>
       </p:sp>
+      <p:sp>
+        <p:nvSpPr>
+          <p:cNvPr id="26" name="TextBox 25">
+            <a:extLst>
+              <a:ext uri="{FF2B5EF4-FFF2-40B4-BE49-F238E27FC236}">
+                <a16:creationId xmlns:a16="http://schemas.microsoft.com/office/drawing/2014/main" id="{8BC5F4EF-49E1-D8EB-6903-816E1D33D297}"/>
+              </a:ext>
+            </a:extLst>
+          </p:cNvPr>
+          <p:cNvSpPr txBox="1"/>
+          <p:nvPr/>
+        </p:nvSpPr>
+        <p:spPr>
+          <a:xfrm>
+            <a:off x="0" y="0"/>
+            <a:ext cx="274625" cy="261610"/>
+          </a:xfrm>
+          <a:prstGeom prst="rect">
+            <a:avLst/>
+          </a:prstGeom>
+          <a:noFill/>
+        </p:spPr>
+        <p:txBody>
+          <a:bodyPr wrap="square" rtlCol="0">
+            <a:spAutoFit/>
+          </a:bodyPr>
+          <a:lstStyle/>
+          <a:p>
+            <a:r>
+              <a:rPr lang="en-US" sz="1100" i="1" dirty="0">
+                <a:solidFill>
+                  <a:schemeClr val="bg1">
+                    <a:lumMod val="50000"/>
+                  </a:schemeClr>
+                </a:solidFill>
+              </a:rPr>
+              <a:t>W</a:t>
+            </a:r>
+          </a:p>
+        </p:txBody>
+      </p:sp>
     </p:spTree>
   </p:cSld>
   <p:clrMapOvr>
@@ -30571,6 +31459,47 @@
           </a:p>
         </p:txBody>
       </p:sp>
+      <p:sp>
+        <p:nvSpPr>
+          <p:cNvPr id="17" name="TextBox 16">
+            <a:extLst>
+              <a:ext uri="{FF2B5EF4-FFF2-40B4-BE49-F238E27FC236}">
+                <a16:creationId xmlns:a16="http://schemas.microsoft.com/office/drawing/2014/main" id="{25E8255F-61AE-CF9B-1613-1E9A4D5AC4F0}"/>
+              </a:ext>
+            </a:extLst>
+          </p:cNvPr>
+          <p:cNvSpPr txBox="1"/>
+          <p:nvPr/>
+        </p:nvSpPr>
+        <p:spPr>
+          <a:xfrm>
+            <a:off x="0" y="0"/>
+            <a:ext cx="274625" cy="261610"/>
+          </a:xfrm>
+          <a:prstGeom prst="rect">
+            <a:avLst/>
+          </a:prstGeom>
+          <a:noFill/>
+        </p:spPr>
+        <p:txBody>
+          <a:bodyPr wrap="square" rtlCol="0">
+            <a:spAutoFit/>
+          </a:bodyPr>
+          <a:lstStyle/>
+          <a:p>
+            <a:r>
+              <a:rPr lang="en-US" sz="1100" i="1" dirty="0">
+                <a:solidFill>
+                  <a:schemeClr val="bg1">
+                    <a:lumMod val="50000"/>
+                  </a:schemeClr>
+                </a:solidFill>
+              </a:rPr>
+              <a:t>W</a:t>
+            </a:r>
+          </a:p>
+        </p:txBody>
+      </p:sp>
     </p:spTree>
   </p:cSld>
   <p:clrMapOvr>
@@ -31488,6 +32417,47 @@
           </a:p>
         </p:txBody>
       </p:sp>
+      <p:sp>
+        <p:nvSpPr>
+          <p:cNvPr id="25" name="TextBox 24">
+            <a:extLst>
+              <a:ext uri="{FF2B5EF4-FFF2-40B4-BE49-F238E27FC236}">
+                <a16:creationId xmlns:a16="http://schemas.microsoft.com/office/drawing/2014/main" id="{E58DF3BE-99AE-A08D-C31D-075133C00287}"/>
+              </a:ext>
+            </a:extLst>
+          </p:cNvPr>
+          <p:cNvSpPr txBox="1"/>
+          <p:nvPr/>
+        </p:nvSpPr>
+        <p:spPr>
+          <a:xfrm>
+            <a:off x="0" y="0"/>
+            <a:ext cx="274625" cy="261610"/>
+          </a:xfrm>
+          <a:prstGeom prst="rect">
+            <a:avLst/>
+          </a:prstGeom>
+          <a:noFill/>
+        </p:spPr>
+        <p:txBody>
+          <a:bodyPr wrap="square" rtlCol="0">
+            <a:spAutoFit/>
+          </a:bodyPr>
+          <a:lstStyle/>
+          <a:p>
+            <a:r>
+              <a:rPr lang="en-US" sz="1100" i="1" dirty="0">
+                <a:solidFill>
+                  <a:schemeClr val="bg1">
+                    <a:lumMod val="50000"/>
+                  </a:schemeClr>
+                </a:solidFill>
+              </a:rPr>
+              <a:t>D</a:t>
+            </a:r>
+          </a:p>
+        </p:txBody>
+      </p:sp>
     </p:spTree>
   </p:cSld>
   <p:clrMapOvr>
@@ -32845,6 +33815,47 @@
           </a:p>
         </p:txBody>
       </p:sp>
+      <p:sp>
+        <p:nvSpPr>
+          <p:cNvPr id="36" name="TextBox 35">
+            <a:extLst>
+              <a:ext uri="{FF2B5EF4-FFF2-40B4-BE49-F238E27FC236}">
+                <a16:creationId xmlns:a16="http://schemas.microsoft.com/office/drawing/2014/main" id="{8F6F287D-4358-D5BA-05D5-BB0CF2312ADE}"/>
+              </a:ext>
+            </a:extLst>
+          </p:cNvPr>
+          <p:cNvSpPr txBox="1"/>
+          <p:nvPr/>
+        </p:nvSpPr>
+        <p:spPr>
+          <a:xfrm>
+            <a:off x="0" y="0"/>
+            <a:ext cx="274625" cy="261610"/>
+          </a:xfrm>
+          <a:prstGeom prst="rect">
+            <a:avLst/>
+          </a:prstGeom>
+          <a:noFill/>
+        </p:spPr>
+        <p:txBody>
+          <a:bodyPr wrap="square" rtlCol="0">
+            <a:spAutoFit/>
+          </a:bodyPr>
+          <a:lstStyle/>
+          <a:p>
+            <a:r>
+              <a:rPr lang="en-US" sz="1100" i="1" dirty="0">
+                <a:solidFill>
+                  <a:schemeClr val="bg1">
+                    <a:lumMod val="50000"/>
+                  </a:schemeClr>
+                </a:solidFill>
+              </a:rPr>
+              <a:t>D</a:t>
+            </a:r>
+          </a:p>
+        </p:txBody>
+      </p:sp>
     </p:spTree>
   </p:cSld>
   <p:clrMapOvr>
@@ -34638,6 +35649,47 @@
             </a:pPr>
             <a:r>
               <a:t>6</a:t>
+            </a:r>
+          </a:p>
+        </p:txBody>
+      </p:sp>
+      <p:sp>
+        <p:nvSpPr>
+          <p:cNvPr id="47" name="TextBox 46">
+            <a:extLst>
+              <a:ext uri="{FF2B5EF4-FFF2-40B4-BE49-F238E27FC236}">
+                <a16:creationId xmlns:a16="http://schemas.microsoft.com/office/drawing/2014/main" id="{F6773956-362B-9870-0C0A-BC9D1B958159}"/>
+              </a:ext>
+            </a:extLst>
+          </p:cNvPr>
+          <p:cNvSpPr txBox="1"/>
+          <p:nvPr/>
+        </p:nvSpPr>
+        <p:spPr>
+          <a:xfrm>
+            <a:off x="0" y="0"/>
+            <a:ext cx="274625" cy="261610"/>
+          </a:xfrm>
+          <a:prstGeom prst="rect">
+            <a:avLst/>
+          </a:prstGeom>
+          <a:noFill/>
+        </p:spPr>
+        <p:txBody>
+          <a:bodyPr wrap="square" rtlCol="0">
+            <a:spAutoFit/>
+          </a:bodyPr>
+          <a:lstStyle/>
+          <a:p>
+            <a:r>
+              <a:rPr lang="en-US" sz="1100" i="1" dirty="0">
+                <a:solidFill>
+                  <a:schemeClr val="bg1">
+                    <a:lumMod val="50000"/>
+                  </a:schemeClr>
+                </a:solidFill>
+              </a:rPr>
+              <a:t>D</a:t>
             </a:r>
           </a:p>
         </p:txBody>

</xml_diff>